<commit_message>
Formación Ajedrez: el peón que no se cambió en la octava se cambia por dama (art. 7.5.2)
El caso de la sesión 1 decía que se reponía la posición anterior. Las Leyes 2023
dicen otra cosa: si el jugador deja el peón en la última fila y presiona el
reloj, la jugada es ilegal, el peón se cambia por una dama del mismo color y se
aplica la sanción de la primera jugada ilegal. Lo señaló la revisión de
Graphify.

Co-Authored-By: Claude Opus 5.5 <noreply@anthropic.com>
Claude-Session: https://claude.ai/code/session_0127yiL7aMDyRSuxN9ZRYVvP
</commit_message>
<xml_diff>
--- a/cursos/recursos/formacion-ajedrez/01-encuadre-y-reglas-basicas.pptx
+++ b/cursos/recursos/formacion-ajedrez/01-encuadre-y-reglas-basicas.pptx
@@ -4339,7 +4339,7 @@
                 </a:solidFill>
                 <a:latin typeface="Calibri"/>
               </a:rPr>
-              <a:t>Es una jugada ilegal completada: el cambio del peón es parte de la misma jugada. Se repone la posición anterior y se aplica la sanción de la primera jugada ilegal.</a:t>
+              <a:t>Es una jugada ilegal completada: el cambio del peón es parte de la misma jugada. No se repone la posición: el peón se cambia por una dama del mismo color y se aplica la sanción de la primera jugada ilegal (dos minutos más para el rival en ritmo clásico, uno en rápidas y relámpago).</a:t>
             </a:r>
           </a:p>
         </p:txBody>
@@ -4373,7 +4373,7 @@
                 </a:solidFill>
                 <a:latin typeface="Calibri"/>
               </a:rPr>
-              <a:t>Fuente: Leyes del Ajedrez 2023 (Handbook E.I.01), art. 3.7.5 y 7.5</a:t>
+              <a:t>Fuente: Leyes del Ajedrez 2023 (Handbook E.I.01), art. 3.7.5, 7.5.2 y 7.5.5</a:t>
             </a:r>
           </a:p>
         </p:txBody>

</xml_diff>

<commit_message>
Ampliar el quiz de la Sesión 1 de Formación Ajedrez con 6 preguntas nuevas
Cubre deberes/imparcialidad del árbitro, qué puede explicar durante la
partida, tablero mal armado, captura al paso, notación y planilla —
contenido que ya traía la sesión pero que el quiz no repasaba.
Regenerado con herramientas/curso-generar-formacion.py,
academia-cabecera.py y datos-estructurados.py; verificado con
herramientas/verificar-formacion.js.

Co-Authored-By: Claude Sonnet 5 <noreply@anthropic.com>
Claude-Session: https://claude.ai/code/session_01JaQt9vJhVtnfamvjJU7GEu
</commit_message>
<xml_diff>
--- a/cursos/recursos/formacion-ajedrez/01-encuadre-y-reglas-basicas.pptx
+++ b/cursos/recursos/formacion-ajedrez/01-encuadre-y-reglas-basicas.pptx
@@ -32647,7 +32647,7 @@
               </a:spcAft>
             </a:pPr>
             <a:r>
-              <a:rPr sz="1400">
+              <a:rPr sz="1200">
                 <a:solidFill>
                   <a:srgbClr val="334E68"/>
                 </a:solidFill>
@@ -32663,7 +32663,7 @@
               </a:spcAft>
             </a:pPr>
             <a:r>
-              <a:rPr sz="1400">
+              <a:rPr sz="1200">
                 <a:solidFill>
                   <a:srgbClr val="334E68"/>
                 </a:solidFill>
@@ -32679,7 +32679,7 @@
               </a:spcAft>
             </a:pPr>
             <a:r>
-              <a:rPr sz="1400">
+              <a:rPr sz="1200">
                 <a:solidFill>
                   <a:srgbClr val="334E68"/>
                 </a:solidFill>
@@ -32695,7 +32695,7 @@
               </a:spcAft>
             </a:pPr>
             <a:r>
-              <a:rPr sz="1400">
+              <a:rPr sz="1200">
                 <a:solidFill>
                   <a:srgbClr val="334E68"/>
                 </a:solidFill>
@@ -32711,7 +32711,7 @@
               </a:spcAft>
             </a:pPr>
             <a:r>
-              <a:rPr sz="1400">
+              <a:rPr sz="1200">
                 <a:solidFill>
                   <a:srgbClr val="334E68"/>
                 </a:solidFill>
@@ -32727,13 +32727,109 @@
               </a:spcAft>
             </a:pPr>
             <a:r>
-              <a:rPr sz="1400">
+              <a:rPr sz="1200">
                 <a:solidFill>
                   <a:srgbClr val="334E68"/>
                 </a:solidFill>
                 <a:latin typeface="Calibri"/>
               </a:rPr>
               <a:t>6. ¿Qué debe anotar cada jugador en su planilla en una partida de ritmo clásico?</a:t>
+            </a:r>
+          </a:p>
+          <a:p>
+            <a:pPr>
+              <a:spcAft>
+                <a:spcPts val="600"/>
+              </a:spcAft>
+            </a:pPr>
+            <a:r>
+              <a:rPr sz="1200">
+                <a:solidFill>
+                  <a:srgbClr val="334E68"/>
+                </a:solidFill>
+                <a:latin typeface="Calibri"/>
+              </a:rPr>
+              <a:t>7. ¿Puede el árbitro principal jugar como participante en el torneo que dirige?</a:t>
+            </a:r>
+          </a:p>
+          <a:p>
+            <a:pPr>
+              <a:spcAft>
+                <a:spcPts val="600"/>
+              </a:spcAft>
+            </a:pPr>
+            <a:r>
+              <a:rPr sz="1200">
+                <a:solidFill>
+                  <a:srgbClr val="334E68"/>
+                </a:solidFill>
+                <a:latin typeface="Calibri"/>
+              </a:rPr>
+              <a:t>8. Un jugador le pide al árbitro que le explique qué significa una regla durante la partida. ¿Puede hacerlo?</a:t>
+            </a:r>
+          </a:p>
+          <a:p>
+            <a:pPr>
+              <a:spcAft>
+                <a:spcPts val="600"/>
+              </a:spcAft>
+            </a:pPr>
+            <a:r>
+              <a:rPr sz="1200">
+                <a:solidFill>
+                  <a:srgbClr val="334E68"/>
+                </a:solidFill>
+                <a:latin typeface="Calibri"/>
+              </a:rPr>
+              <a:t>9. Se descubre a mitad de partida que la posición inicial estaba mal armada desde el principio. ¿Qué corresponde?</a:t>
+            </a:r>
+          </a:p>
+          <a:p>
+            <a:pPr>
+              <a:spcAft>
+                <a:spcPts val="600"/>
+              </a:spcAft>
+            </a:pPr>
+            <a:r>
+              <a:rPr sz="1200">
+                <a:solidFill>
+                  <a:srgbClr val="334E68"/>
+                </a:solidFill>
+                <a:latin typeface="Calibri"/>
+              </a:rPr>
+              <a:t>10. ¿Hasta qué momento es legal capturar un peón al paso?</a:t>
+            </a:r>
+          </a:p>
+          <a:p>
+            <a:pPr>
+              <a:spcAft>
+                <a:spcPts val="600"/>
+              </a:spcAft>
+            </a:pPr>
+            <a:r>
+              <a:rPr sz="1200">
+                <a:solidFill>
+                  <a:srgbClr val="334E68"/>
+                </a:solidFill>
+                <a:latin typeface="Calibri"/>
+              </a:rPr>
+              <a:t>11. ¿Qué letras se usan en español para las piezas al anotar una partida en notación algebraica?</a:t>
+            </a:r>
+          </a:p>
+          <a:p>
+            <a:pPr>
+              <a:spcAft>
+                <a:spcPts val="600"/>
+              </a:spcAft>
+            </a:pPr>
+            <a:r>
+              <a:rPr sz="1200">
+                <a:solidFill>
+                  <a:srgbClr val="334E68"/>
+                </a:solidFill>
+                <a:latin typeface="Calibri"/>
+              </a:rPr>
+              <a:t>12. ¿Puede un jugador escribir en la planilla una jugada antes de hacerla en el tablero?</a:t>
             </a:r>
           </a:p>
         </p:txBody>

</xml_diff>

<commit_message>
Ampliar el quiz de la Sesión 1 de Formación Ajedrez (#780)
Cubre deberes/imparcialidad del árbitro, qué puede explicar durante la
partida, tablero mal armado, captura al paso, notación y planilla —
contenido que ya traía la sesión pero que el quiz no repasaba.
Regenerado con herramientas/curso-generar-formacion.py,
academia-cabecera.py y datos-estructurados.py; verificado con
herramientas/verificar-formacion.js.


Claude-Session: https://claude.ai/code/session_01JaQt9vJhVtnfamvjJU7GEu

Co-authored-by: Claude <noreply@anthropic.com>
</commit_message>
<xml_diff>
--- a/cursos/recursos/formacion-ajedrez/01-encuadre-y-reglas-basicas.pptx
+++ b/cursos/recursos/formacion-ajedrez/01-encuadre-y-reglas-basicas.pptx
@@ -32647,7 +32647,7 @@
               </a:spcAft>
             </a:pPr>
             <a:r>
-              <a:rPr sz="1400">
+              <a:rPr sz="1200">
                 <a:solidFill>
                   <a:srgbClr val="334E68"/>
                 </a:solidFill>
@@ -32663,7 +32663,7 @@
               </a:spcAft>
             </a:pPr>
             <a:r>
-              <a:rPr sz="1400">
+              <a:rPr sz="1200">
                 <a:solidFill>
                   <a:srgbClr val="334E68"/>
                 </a:solidFill>
@@ -32679,7 +32679,7 @@
               </a:spcAft>
             </a:pPr>
             <a:r>
-              <a:rPr sz="1400">
+              <a:rPr sz="1200">
                 <a:solidFill>
                   <a:srgbClr val="334E68"/>
                 </a:solidFill>
@@ -32695,7 +32695,7 @@
               </a:spcAft>
             </a:pPr>
             <a:r>
-              <a:rPr sz="1400">
+              <a:rPr sz="1200">
                 <a:solidFill>
                   <a:srgbClr val="334E68"/>
                 </a:solidFill>
@@ -32711,7 +32711,7 @@
               </a:spcAft>
             </a:pPr>
             <a:r>
-              <a:rPr sz="1400">
+              <a:rPr sz="1200">
                 <a:solidFill>
                   <a:srgbClr val="334E68"/>
                 </a:solidFill>
@@ -32727,13 +32727,109 @@
               </a:spcAft>
             </a:pPr>
             <a:r>
-              <a:rPr sz="1400">
+              <a:rPr sz="1200">
                 <a:solidFill>
                   <a:srgbClr val="334E68"/>
                 </a:solidFill>
                 <a:latin typeface="Calibri"/>
               </a:rPr>
               <a:t>6. ¿Qué debe anotar cada jugador en su planilla en una partida de ritmo clásico?</a:t>
+            </a:r>
+          </a:p>
+          <a:p>
+            <a:pPr>
+              <a:spcAft>
+                <a:spcPts val="600"/>
+              </a:spcAft>
+            </a:pPr>
+            <a:r>
+              <a:rPr sz="1200">
+                <a:solidFill>
+                  <a:srgbClr val="334E68"/>
+                </a:solidFill>
+                <a:latin typeface="Calibri"/>
+              </a:rPr>
+              <a:t>7. ¿Puede el árbitro principal jugar como participante en el torneo que dirige?</a:t>
+            </a:r>
+          </a:p>
+          <a:p>
+            <a:pPr>
+              <a:spcAft>
+                <a:spcPts val="600"/>
+              </a:spcAft>
+            </a:pPr>
+            <a:r>
+              <a:rPr sz="1200">
+                <a:solidFill>
+                  <a:srgbClr val="334E68"/>
+                </a:solidFill>
+                <a:latin typeface="Calibri"/>
+              </a:rPr>
+              <a:t>8. Un jugador le pide al árbitro que le explique qué significa una regla durante la partida. ¿Puede hacerlo?</a:t>
+            </a:r>
+          </a:p>
+          <a:p>
+            <a:pPr>
+              <a:spcAft>
+                <a:spcPts val="600"/>
+              </a:spcAft>
+            </a:pPr>
+            <a:r>
+              <a:rPr sz="1200">
+                <a:solidFill>
+                  <a:srgbClr val="334E68"/>
+                </a:solidFill>
+                <a:latin typeface="Calibri"/>
+              </a:rPr>
+              <a:t>9. Se descubre a mitad de partida que la posición inicial estaba mal armada desde el principio. ¿Qué corresponde?</a:t>
+            </a:r>
+          </a:p>
+          <a:p>
+            <a:pPr>
+              <a:spcAft>
+                <a:spcPts val="600"/>
+              </a:spcAft>
+            </a:pPr>
+            <a:r>
+              <a:rPr sz="1200">
+                <a:solidFill>
+                  <a:srgbClr val="334E68"/>
+                </a:solidFill>
+                <a:latin typeface="Calibri"/>
+              </a:rPr>
+              <a:t>10. ¿Hasta qué momento es legal capturar un peón al paso?</a:t>
+            </a:r>
+          </a:p>
+          <a:p>
+            <a:pPr>
+              <a:spcAft>
+                <a:spcPts val="600"/>
+              </a:spcAft>
+            </a:pPr>
+            <a:r>
+              <a:rPr sz="1200">
+                <a:solidFill>
+                  <a:srgbClr val="334E68"/>
+                </a:solidFill>
+                <a:latin typeface="Calibri"/>
+              </a:rPr>
+              <a:t>11. ¿Qué letras se usan en español para las piezas al anotar una partida en notación algebraica?</a:t>
+            </a:r>
+          </a:p>
+          <a:p>
+            <a:pPr>
+              <a:spcAft>
+                <a:spcPts val="600"/>
+              </a:spcAft>
+            </a:pPr>
+            <a:r>
+              <a:rPr sz="1200">
+                <a:solidFill>
+                  <a:srgbClr val="334E68"/>
+                </a:solidFill>
+                <a:latin typeface="Calibri"/>
+              </a:rPr>
+              <a:t>12. ¿Puede un jugador escribir en la planilla una jugada antes de hacerla en el tablero?</a:t>
             </a:r>
           </a:p>
         </p:txBody>

</xml_diff>

<commit_message>
Formación Ajedrez: 7 sesiones (6 virtuales de 4 h + presencial de 6 h el 14 de diciembre) (#852)
Se fusionan las sesiones 3 y 4 (apéndices, normativa JDE y sistemas de emparejamiento), se renumeran las siguientes y los cronogramas virtuales pasan a 240 minutos con el mismo contenido; la presencial del 14 de diciembre dura 6 horas (8:00 a. m. a 2:00 p. m.). La Clase 1 rehace sus láminas de mapa, cronograma, recesos, práctica y tarea, y suma las 12 láminas del PowerPoint del profe. Catálogo, tienda, Kahoot, Campeones Colegiales y la base (curso_lecciones 8 → 7) quedan al día.

Co-Authored-By: Claude Opus 5.5 <noreply@anthropic.com>
Claude-Session: https://claude.ai/code/session_01Xku4QMHnGUjFxLz5GZH1RP
</commit_message>
<xml_diff>
--- a/cursos/recursos/formacion-ajedrez/01-encuadre-y-reglas-basicas.pptx
+++ b/cursos/recursos/formacion-ajedrez/01-encuadre-y-reglas-basicas.pptx
@@ -8156,7 +8156,7 @@
                 </a:solidFill>
                 <a:latin typeface="Calibri"/>
               </a:rPr>
-              <a:t>15 minutos</a:t>
+              <a:t>10 minutos</a:t>
             </a:r>
           </a:p>
           <a:p>
@@ -10331,7 +10331,7 @@
                 </a:solidFill>
                 <a:latin typeface="Calibri"/>
               </a:rPr>
-              <a:t>Sesión 1 · 5 horas (300 minutos)</a:t>
+              <a:t>Sesión 1 · 4 horas (240 minutos)</a:t>
             </a:r>
           </a:p>
         </p:txBody>
@@ -10479,7 +10479,7 @@
                           </a:solidFill>
                           <a:latin typeface="Calibri"/>
                         </a:rPr>
-                        <a:t>0:00 – 0:15</a:t>
+                        <a:t>0:00 – 0:10</a:t>
                       </a:r>
                     </a:p>
                   </a:txBody>
@@ -10501,7 +10501,7 @@
                           </a:solidFill>
                           <a:latin typeface="Calibri"/>
                         </a:rPr>
-                        <a:t>15 min</a:t>
+                        <a:t>10 min</a:t>
                       </a:r>
                     </a:p>
                   </a:txBody>
@@ -10547,7 +10547,7 @@
                           </a:solidFill>
                           <a:latin typeface="Calibri"/>
                         </a:rPr>
-                        <a:t>0:15 – 0:45</a:t>
+                        <a:t>0:10 – 0:35</a:t>
                       </a:r>
                     </a:p>
                   </a:txBody>
@@ -10569,7 +10569,7 @@
                           </a:solidFill>
                           <a:latin typeface="Calibri"/>
                         </a:rPr>
-                        <a:t>30 min</a:t>
+                        <a:t>25 min</a:t>
                       </a:r>
                     </a:p>
                   </a:txBody>
@@ -10615,7 +10615,7 @@
                           </a:solidFill>
                           <a:latin typeface="Calibri"/>
                         </a:rPr>
-                        <a:t>0:45 – 1:30</a:t>
+                        <a:t>0:35 – 1:15</a:t>
                       </a:r>
                     </a:p>
                   </a:txBody>
@@ -10637,7 +10637,7 @@
                           </a:solidFill>
                           <a:latin typeface="Calibri"/>
                         </a:rPr>
-                        <a:t>45 min</a:t>
+                        <a:t>40 min</a:t>
                       </a:r>
                     </a:p>
                   </a:txBody>
@@ -10683,7 +10683,7 @@
                           </a:solidFill>
                           <a:latin typeface="Calibri"/>
                         </a:rPr>
-                        <a:t>1:30 – 1:45</a:t>
+                        <a:t>1:15 – 1:25</a:t>
                       </a:r>
                     </a:p>
                   </a:txBody>
@@ -10705,7 +10705,7 @@
                           </a:solidFill>
                           <a:latin typeface="Calibri"/>
                         </a:rPr>
-                        <a:t>15 min</a:t>
+                        <a:t>10 min</a:t>
                       </a:r>
                     </a:p>
                   </a:txBody>
@@ -10751,7 +10751,7 @@
                           </a:solidFill>
                           <a:latin typeface="Calibri"/>
                         </a:rPr>
-                        <a:t>1:45 – 2:30</a:t>
+                        <a:t>1:25 – 2:00</a:t>
                       </a:r>
                     </a:p>
                   </a:txBody>
@@ -10773,7 +10773,7 @@
                           </a:solidFill>
                           <a:latin typeface="Calibri"/>
                         </a:rPr>
-                        <a:t>45 min</a:t>
+                        <a:t>35 min</a:t>
                       </a:r>
                     </a:p>
                   </a:txBody>
@@ -10819,7 +10819,7 @@
                           </a:solidFill>
                           <a:latin typeface="Calibri"/>
                         </a:rPr>
-                        <a:t>2:30 – 3:00</a:t>
+                        <a:t>2:00 – 2:25</a:t>
                       </a:r>
                     </a:p>
                   </a:txBody>
@@ -10841,7 +10841,7 @@
                           </a:solidFill>
                           <a:latin typeface="Calibri"/>
                         </a:rPr>
-                        <a:t>30 min</a:t>
+                        <a:t>25 min</a:t>
                       </a:r>
                     </a:p>
                   </a:txBody>
@@ -10887,7 +10887,7 @@
                           </a:solidFill>
                           <a:latin typeface="Calibri"/>
                         </a:rPr>
-                        <a:t>3:00 – 3:15</a:t>
+                        <a:t>2:25 – 2:35</a:t>
                       </a:r>
                     </a:p>
                   </a:txBody>
@@ -10909,7 +10909,7 @@
                           </a:solidFill>
                           <a:latin typeface="Calibri"/>
                         </a:rPr>
-                        <a:t>15 min</a:t>
+                        <a:t>10 min</a:t>
                       </a:r>
                     </a:p>
                   </a:txBody>
@@ -10955,7 +10955,7 @@
                           </a:solidFill>
                           <a:latin typeface="Calibri"/>
                         </a:rPr>
-                        <a:t>3:15 – 4:05</a:t>
+                        <a:t>2:35 – 3:15</a:t>
                       </a:r>
                     </a:p>
                   </a:txBody>
@@ -10977,7 +10977,7 @@
                           </a:solidFill>
                           <a:latin typeface="Calibri"/>
                         </a:rPr>
-                        <a:t>50 min</a:t>
+                        <a:t>40 min</a:t>
                       </a:r>
                     </a:p>
                   </a:txBody>
@@ -11023,7 +11023,7 @@
                           </a:solidFill>
                           <a:latin typeface="Calibri"/>
                         </a:rPr>
-                        <a:t>4:05 – 4:40</a:t>
+                        <a:t>3:15 – 3:45</a:t>
                       </a:r>
                     </a:p>
                   </a:txBody>
@@ -11045,7 +11045,7 @@
                           </a:solidFill>
                           <a:latin typeface="Calibri"/>
                         </a:rPr>
-                        <a:t>35 min</a:t>
+                        <a:t>30 min</a:t>
                       </a:r>
                     </a:p>
                   </a:txBody>
@@ -11091,7 +11091,7 @@
                           </a:solidFill>
                           <a:latin typeface="Calibri"/>
                         </a:rPr>
-                        <a:t>4:40 – 5:00</a:t>
+                        <a:t>3:45 – 4:00</a:t>
                       </a:r>
                     </a:p>
                   </a:txBody>
@@ -11113,7 +11113,7 @@
                           </a:solidFill>
                           <a:latin typeface="Calibri"/>
                         </a:rPr>
-                        <a:t>20 min</a:t>
+                        <a:t>15 min</a:t>
                       </a:r>
                     </a:p>
                   </a:txBody>
@@ -14686,7 +14686,7 @@
                 </a:solidFill>
                 <a:latin typeface="Calibri"/>
               </a:rPr>
-              <a:t>15 minutos</a:t>
+              <a:t>10 minutos</a:t>
             </a:r>
           </a:p>
           <a:p>

</xml_diff>